<commit_message>
Improve Math 130 Unit 3C slide deck for clarity and learning
- Add Skill 2 word problem slide (ladder/right triangle, 6-step solution)
- Add You Try practice slide (angle-of-elevation, with diagram)
- Insert missing algebra step in two-triangle derivation (slide 14)
- Upgrade DEGREE mode warning to a visible red callout box (slide 7)
- Fix color consistency: Solution: → green, Vertical header → teal,
  Depression transition line → teal, Summary footer → teal bold
- Add WIP folder with HANDOFF.md, diagrams.py, build_pptx.py, and
  two new matplotlib diagrams (ladder + elevation)
- PDF/PNG re-export pending local LibreOffice (PPTX is source of truth)

https://claude.ai/code/session_01SAFezDac2o6tfRpFGhfbvt
</commit_message>
<xml_diff>
--- a/slides/Math130Unit3C.pptx
+++ b/slides/Math130Unit3C.pptx
@@ -13,6 +13,7 @@
     <p:sldId id="258" r:id="rId4"/>
     <p:sldId id="259" r:id="rId5"/>
     <p:sldId id="260" r:id="rId6"/>
+    <p:sldId id="273" r:id="rId26"/>
     <p:sldId id="261" r:id="rId7"/>
     <p:sldId id="262" r:id="rId8"/>
     <p:sldId id="263" r:id="rId9"/>
@@ -21,6 +22,7 @@
     <p:sldId id="266" r:id="rId12"/>
     <p:sldId id="267" r:id="rId13"/>
     <p:sldId id="268" r:id="rId14"/>
+    <p:sldId id="274" r:id="rId27"/>
     <p:sldId id="269" r:id="rId15"/>
     <p:sldId id="270" r:id="rId16"/>
     <p:sldId id="271" r:id="rId17"/>
@@ -3853,195 +3855,107 @@
               <a:buNone/>
             </a:pPr>
             <a:r>
-              <a:rPr lang="en-US" sz="1300" b="1" dirty="0">
+              <a:rPr sz="1650" b="1">
                 <a:solidFill>
                   <a:srgbClr val="0891B2"/>
                 </a:solidFill>
-                <a:latin typeface="Georgia" pitchFamily="34" charset="0"/>
-                <a:ea typeface="Georgia" pitchFamily="34" charset="-122"/>
-                <a:cs typeface="Georgia" pitchFamily="34" charset="-120"/>
+                <a:latin typeface="Calibri"/>
               </a:rPr>
               <a:t>Set up two equations:</a:t>
             </a:r>
             <a:endParaRPr lang="en-US" sz="1300" dirty="0"/>
           </a:p>
           <a:p>
-            <a:pPr marL="0" indent="0">
-              <a:spcAft>
-                <a:spcPts val="100"/>
-              </a:spcAft>
-              <a:buNone/>
-            </a:pPr>
-            <a:r>
-              <a:rPr lang="en-US" sz="1300" dirty="0">
+            <a:r>
+              <a:rPr sz="1650" b="0">
                 <a:solidFill>
                   <a:srgbClr val="0891B2"/>
                 </a:solidFill>
-                <a:latin typeface="Calibri" pitchFamily="34" charset="0"/>
-                <a:ea typeface="Calibri" pitchFamily="34" charset="-122"/>
-                <a:cs typeface="Calibri" pitchFamily="34" charset="-120"/>
+                <a:latin typeface="Calibri"/>
               </a:rPr>
               <a:t>Closer: tan 53° = h / d</a:t>
             </a:r>
-            <a:endParaRPr lang="en-US" sz="1300" dirty="0"/>
-          </a:p>
-          <a:p>
-            <a:pPr marL="0" indent="0">
-              <a:spcAft>
-                <a:spcPts val="100"/>
-              </a:spcAft>
-              <a:buNone/>
-            </a:pPr>
-            <a:r>
-              <a:rPr lang="en-US" sz="1300" dirty="0">
+          </a:p>
+          <a:p>
+            <a:r>
+              <a:rPr sz="1650" b="0">
                 <a:solidFill>
                   <a:srgbClr val="F97316"/>
                 </a:solidFill>
-                <a:latin typeface="Calibri" pitchFamily="34" charset="0"/>
-                <a:ea typeface="Calibri" pitchFamily="34" charset="-122"/>
-                <a:cs typeface="Calibri" pitchFamily="34" charset="-120"/>
+                <a:latin typeface="Calibri"/>
               </a:rPr>
               <a:t>Farther: tan 31° = h / (d + 50)</a:t>
             </a:r>
-            <a:endParaRPr lang="en-US" sz="1300" dirty="0"/>
-          </a:p>
-          <a:p>
-            <a:pPr marL="0" indent="0">
-              <a:spcAft>
-                <a:spcPts val="100"/>
-              </a:spcAft>
-              <a:buNone/>
-            </a:pPr>
-            <a:endParaRPr lang="en-US" sz="1300" dirty="0"/>
-          </a:p>
-          <a:p>
-            <a:pPr marL="0" indent="0">
-              <a:spcAft>
-                <a:spcPts val="100"/>
-              </a:spcAft>
-              <a:buNone/>
-            </a:pPr>
-            <a:r>
-              <a:rPr lang="en-US" sz="1300" b="1" dirty="0">
+          </a:p>
+          <a:p/>
+          <a:p>
+            <a:r>
+              <a:rPr sz="1650" b="1">
                 <a:solidFill>
                   <a:srgbClr val="7C3AED"/>
                 </a:solidFill>
-                <a:latin typeface="Georgia" pitchFamily="34" charset="0"/>
-                <a:ea typeface="Georgia" pitchFamily="34" charset="-122"/>
-                <a:cs typeface="Georgia" pitchFamily="34" charset="-120"/>
+                <a:latin typeface="Calibri"/>
               </a:rPr>
               <a:t>Solve: h = d tan 53° = (d+50) tan 31°</a:t>
             </a:r>
-            <a:endParaRPr lang="en-US" sz="1300" dirty="0"/>
-          </a:p>
-          <a:p>
-            <a:pPr marL="0" indent="0">
-              <a:spcAft>
-                <a:spcPts val="100"/>
-              </a:spcAft>
-              <a:buNone/>
-            </a:pPr>
-            <a:r>
-              <a:rPr lang="en-US" sz="1300" dirty="0">
-                <a:solidFill>
-                  <a:srgbClr val="1E293B"/>
-                </a:solidFill>
-                <a:latin typeface="Calibri" pitchFamily="34" charset="0"/>
-                <a:ea typeface="Calibri" pitchFamily="34" charset="-122"/>
-                <a:cs typeface="Calibri" pitchFamily="34" charset="-120"/>
+          </a:p>
+          <a:p>
+            <a:r>
+              <a:rPr sz="1500">
+                <a:latin typeface="Calibri"/>
               </a:rPr>
               <a:t>d(1.327) = d(0.601) + 50(0.601)</a:t>
             </a:r>
-            <a:endParaRPr lang="en-US" sz="1300" dirty="0"/>
-          </a:p>
-          <a:p>
-            <a:pPr marL="0" indent="0">
-              <a:spcAft>
-                <a:spcPts val="100"/>
-              </a:spcAft>
-              <a:buNone/>
-            </a:pPr>
-            <a:r>
-              <a:rPr lang="en-US" sz="1300" dirty="0">
-                <a:solidFill>
-                  <a:srgbClr val="1E293B"/>
-                </a:solidFill>
-                <a:latin typeface="Calibri" pitchFamily="34" charset="0"/>
-                <a:ea typeface="Calibri" pitchFamily="34" charset="-122"/>
-                <a:cs typeface="Calibri" pitchFamily="34" charset="-120"/>
+          </a:p>
+          <a:p>
+            <a:r>
+              <a:rPr sz="1400" b="0">
+                <a:solidFill>
+                  <a:srgbClr val="64748B"/>
+                </a:solidFill>
+                <a:latin typeface="Calibri"/>
+              </a:rPr>
+              <a:t>d(1.327 − 0.601) = 50 × 0.601</a:t>
+            </a:r>
+          </a:p>
+          <a:p>
+            <a:r>
+              <a:rPr sz="1500">
+                <a:latin typeface="Calibri"/>
               </a:rPr>
               <a:t>d(0.726) = 30.04</a:t>
             </a:r>
-            <a:endParaRPr lang="en-US" sz="1300" dirty="0"/>
-          </a:p>
-          <a:p>
-            <a:pPr marL="0" indent="0">
-              <a:spcAft>
-                <a:spcPts val="100"/>
-              </a:spcAft>
-              <a:buNone/>
-            </a:pPr>
-            <a:r>
-              <a:rPr lang="en-US" sz="1400" b="1" dirty="0">
+          </a:p>
+          <a:p>
+            <a:r>
+              <a:rPr sz="1500">
+                <a:latin typeface="Calibri"/>
+              </a:rPr>
+              <a:t>d ≈ 41.4 ft</a:t>
+            </a:r>
+          </a:p>
+          <a:p/>
+          <a:p>
+            <a:r>
+              <a:rPr sz="1500" b="0">
                 <a:solidFill>
                   <a:srgbClr val="0891B2"/>
                 </a:solidFill>
-                <a:latin typeface="Calibri" pitchFamily="34" charset="0"/>
-                <a:ea typeface="Calibri" pitchFamily="34" charset="-122"/>
-                <a:cs typeface="Calibri" pitchFamily="34" charset="-120"/>
-              </a:rPr>
-              <a:t>d ≈ 41.4 ft</a:t>
-            </a:r>
-            <a:endParaRPr lang="en-US" sz="1300" dirty="0"/>
-          </a:p>
-          <a:p>
-            <a:pPr marL="0" indent="0">
-              <a:spcAft>
-                <a:spcPts val="100"/>
-              </a:spcAft>
-              <a:buNone/>
-            </a:pPr>
-            <a:endParaRPr lang="en-US" sz="1300" dirty="0"/>
-          </a:p>
-          <a:p>
-            <a:pPr marL="0" indent="0">
-              <a:spcAft>
-                <a:spcPts val="100"/>
-              </a:spcAft>
-              <a:buNone/>
-            </a:pPr>
-            <a:r>
-              <a:rPr lang="en-US" sz="1300" dirty="0">
-                <a:solidFill>
-                  <a:srgbClr val="1E293B"/>
-                </a:solidFill>
-                <a:latin typeface="Calibri" pitchFamily="34" charset="0"/>
-                <a:ea typeface="Calibri" pitchFamily="34" charset="-122"/>
-                <a:cs typeface="Calibri" pitchFamily="34" charset="-120"/>
+                <a:latin typeface="Calibri"/>
               </a:rPr>
               <a:t>h = 41.4 × tan 53° ≈ 41.4 × 1.327</a:t>
             </a:r>
-            <a:endParaRPr lang="en-US" sz="1300" dirty="0"/>
-          </a:p>
-          <a:p>
-            <a:pPr marL="0" indent="0">
-              <a:spcAft>
-                <a:spcPts val="100"/>
-              </a:spcAft>
-              <a:buNone/>
-            </a:pPr>
-            <a:r>
-              <a:rPr lang="en-US" sz="1700" b="1" dirty="0">
+          </a:p>
+          <a:p>
+            <a:r>
+              <a:rPr sz="1650" b="1">
                 <a:solidFill>
                   <a:srgbClr val="F97316"/>
                 </a:solidFill>
-                <a:latin typeface="Georgia" pitchFamily="34" charset="0"/>
-                <a:ea typeface="Georgia" pitchFamily="34" charset="-122"/>
-                <a:cs typeface="Georgia" pitchFamily="34" charset="-120"/>
+                <a:latin typeface="Calibri"/>
               </a:rPr>
               <a:t>h ≈ 54.9 ft</a:t>
             </a:r>
-            <a:endParaRPr lang="en-US" sz="1300" dirty="0"/>
           </a:p>
         </p:txBody>
       </p:sp>
@@ -5098,7 +5012,7 @@
             <a:r>
               <a:rPr lang="en-US" sz="1400" b="1" dirty="0">
                 <a:solidFill>
-                  <a:srgbClr val="F97316"/>
+                  <a:srgbClr val="059669"/>
                 </a:solidFill>
                 <a:latin typeface="Calibri" pitchFamily="34" charset="0"/>
                 <a:ea typeface="Calibri" pitchFamily="34" charset="-122"/>
@@ -5993,8 +5907,8 @@
         </p:nvSpPr>
         <p:spPr>
           <a:xfrm>
-            <a:off x="731520" y="4572000"/>
-            <a:ext cx="7315200" cy="365760"/>
+            <a:off x="731520" y="4407408"/>
+            <a:ext cx="7315200" cy="411480"/>
           </a:xfrm>
           <a:prstGeom prst="rect">
             <a:avLst/>
@@ -6010,9 +5924,9 @@
               <a:buNone/>
             </a:pPr>
             <a:r>
-              <a:rPr lang="en-US" sz="1300" i="1" dirty="0">
-                <a:solidFill>
-                  <a:srgbClr val="64748B"/>
+              <a:rPr lang="en-US" sz="1500" i="0" dirty="0" b="1">
+                <a:solidFill>
+                  <a:srgbClr val="0891B2"/>
                 </a:solidFill>
                 <a:latin typeface="Calibri" pitchFamily="34" charset="0"/>
                 <a:ea typeface="Calibri" pitchFamily="34" charset="-122"/>
@@ -6024,6 +5938,541 @@
           </a:p>
         </p:txBody>
       </p:sp>
+    </p:spTree>
+  </p:cSld>
+  <p:clrMapOvr>
+    <a:masterClrMapping/>
+  </p:clrMapOvr>
+</p:sld>
+</file>
+
+<file path=ppt/slides/slide18.xml><?xml version="1.0" encoding="utf-8"?>
+<p:sld xmlns:a="http://schemas.openxmlformats.org/drawingml/2006/main" xmlns:p="http://schemas.openxmlformats.org/presentationml/2006/main" xmlns:r="http://schemas.openxmlformats.org/officeDocument/2006/relationships">
+  <p:cSld>
+    <p:spTree>
+      <p:nvGrpSpPr>
+        <p:cNvPr id="1" name=""/>
+        <p:cNvGrpSpPr/>
+        <p:nvPr/>
+      </p:nvGrpSpPr>
+      <p:grpSpPr/>
+      <p:sp>
+        <p:nvSpPr>
+          <p:cNvPr id="2" name="Text 0"/>
+          <p:cNvSpPr/>
+          <p:nvPr/>
+        </p:nvSpPr>
+        <p:spPr>
+          <a:xfrm>
+            <a:off x="548640" y="274320"/>
+            <a:ext cx="8229600" cy="548640"/>
+          </a:xfrm>
+          <a:prstGeom prst="rect">
+            <a:avLst/>
+          </a:prstGeom>
+          <a:noFill/>
+          <a:ln/>
+        </p:spPr>
+        <p:txBody>
+          <a:bodyPr wrap="square" lIns="0" tIns="0" rIns="0" bIns="0" rtlCol="0" anchor="ctr"/>
+          <a:lstStyle/>
+          <a:p>
+            <a:pPr marL="0" indent="0">
+              <a:buNone/>
+            </a:pPr>
+            <a:r>
+              <a:rPr sz="3300" b="1">
+                <a:solidFill>
+                  <a:srgbClr val="1E3A5F"/>
+                </a:solidFill>
+                <a:latin typeface="Georgia"/>
+              </a:rPr>
+              <a:t>Word Problem — One Right Triangle</a:t>
+            </a:r>
+            <a:endParaRPr lang="en-US" sz="2800" dirty="0"/>
+          </a:p>
+        </p:txBody>
+      </p:sp>
+      <p:sp>
+        <p:nvSpPr>
+          <p:cNvPr id="3" name="Shape 1"/>
+          <p:cNvSpPr/>
+          <p:nvPr/>
+        </p:nvSpPr>
+        <p:spPr>
+          <a:xfrm>
+            <a:off x="457200" y="868680"/>
+            <a:ext cx="8229600" cy="502920"/>
+          </a:xfrm>
+          <a:prstGeom prst="rect">
+            <a:avLst/>
+          </a:prstGeom>
+          <a:solidFill>
+            <a:srgbClr val="0F2B46"/>
+          </a:solidFill>
+          <a:ln/>
+        </p:spPr>
+        <p:txBody>
+          <a:bodyPr/>
+          <a:lstStyle/>
+          <a:p>
+            <a:endParaRPr lang="en-US"/>
+          </a:p>
+        </p:txBody>
+      </p:sp>
+      <p:sp>
+        <p:nvSpPr>
+          <p:cNvPr id="4" name="Text 2"/>
+          <p:cNvSpPr/>
+          <p:nvPr/>
+        </p:nvSpPr>
+        <p:spPr>
+          <a:xfrm>
+            <a:off x="640080" y="868680"/>
+            <a:ext cx="7772400" cy="502920"/>
+          </a:xfrm>
+          <a:prstGeom prst="rect">
+            <a:avLst/>
+          </a:prstGeom>
+          <a:noFill/>
+          <a:ln/>
+        </p:spPr>
+        <p:txBody>
+          <a:bodyPr wrap="square" lIns="0" tIns="0" rIns="0" bIns="0" rtlCol="0" anchor="ctr"/>
+          <a:lstStyle/>
+          <a:p>
+            <a:pPr marL="0" indent="0">
+              <a:buNone/>
+            </a:pPr>
+            <a:r>
+              <a:rPr sz="1700" b="0">
+                <a:solidFill>
+                  <a:srgbClr val="FFFFFF"/>
+                </a:solidFill>
+                <a:latin typeface="Calibri"/>
+              </a:rPr>
+              <a:t>A 20 ft ladder leans against a wall at 65° from the ground. How high up the wall does it reach?</a:t>
+            </a:r>
+            <a:endParaRPr lang="en-US" sz="1500" dirty="0"/>
+          </a:p>
+        </p:txBody>
+      </p:sp>
+      <p:sp>
+        <p:nvSpPr>
+          <p:cNvPr id="6" name="Text 4"/>
+          <p:cNvSpPr/>
+          <p:nvPr/>
+        </p:nvSpPr>
+        <p:spPr>
+          <a:xfrm>
+            <a:off x="640080" y="1737360"/>
+            <a:ext cx="7680960" cy="2286000"/>
+          </a:xfrm>
+          <a:prstGeom prst="rect">
+            <a:avLst/>
+          </a:prstGeom>
+          <a:noFill/>
+          <a:ln/>
+        </p:spPr>
+        <p:txBody>
+          <a:bodyPr wrap="square" rtlCol="0" anchor="ctr"/>
+          <a:lstStyle/>
+          <a:p>
+            <a:pPr marL="0" indent="0">
+              <a:spcAft>
+                <a:spcPts val="300"/>
+              </a:spcAft>
+              <a:buNone/>
+            </a:pPr>
+            <a:r>
+              <a:rPr sz="1700" b="1">
+                <a:solidFill>
+                  <a:srgbClr val="0891B2"/>
+                </a:solidFill>
+                <a:latin typeface="Calibri"/>
+              </a:rPr>
+              <a:t>Step 1: Identify</a:t>
+            </a:r>
+            <a:endParaRPr lang="en-US" sz="1500" dirty="0"/>
+          </a:p>
+          <a:p>
+            <a:r>
+              <a:rPr sz="1600">
+                <a:latin typeface="Calibri"/>
+              </a:rPr>
+              <a:t>Hyp = 20 ft,  angle = 65°,  find opposite (wall height) → use sin (SOH)</a:t>
+            </a:r>
+          </a:p>
+          <a:p/>
+          <a:p>
+            <a:r>
+              <a:rPr sz="1700" b="1">
+                <a:solidFill>
+                  <a:srgbClr val="F97316"/>
+                </a:solidFill>
+                <a:latin typeface="Calibri"/>
+              </a:rPr>
+              <a:t>Step 2: Set up</a:t>
+            </a:r>
+          </a:p>
+          <a:p>
+            <a:r>
+              <a:rPr sz="1700">
+                <a:latin typeface="Calibri"/>
+              </a:rPr>
+              <a:t>sin 65° = h / 20</a:t>
+            </a:r>
+          </a:p>
+          <a:p/>
+          <a:p>
+            <a:r>
+              <a:rPr sz="1700" b="1">
+                <a:solidFill>
+                  <a:srgbClr val="7C3AED"/>
+                </a:solidFill>
+                <a:latin typeface="Calibri"/>
+              </a:rPr>
+              <a:t>Step 3: Solve</a:t>
+            </a:r>
+          </a:p>
+          <a:p>
+            <a:r>
+              <a:rPr sz="1700">
+                <a:latin typeface="Calibri"/>
+              </a:rPr>
+              <a:t>h = 20 × sin 65° = 20 × 0.9063 ≈ 18.1 ft</a:t>
+            </a:r>
+          </a:p>
+          <a:p/>
+          <a:p>
+            <a:r>
+              <a:rPr sz="1700" b="1">
+                <a:solidFill>
+                  <a:srgbClr val="059669"/>
+                </a:solidFill>
+                <a:latin typeface="Calibri"/>
+              </a:rPr>
+              <a:t>Check:</a:t>
+            </a:r>
+          </a:p>
+          <a:p>
+            <a:r>
+              <a:rPr sz="1500" b="0">
+                <a:latin typeface="Calibri"/>
+              </a:rPr>
+              <a:t>18.1 &lt; 20 ✓ (opposite &lt; hypotenuse)</a:t>
+            </a:r>
+          </a:p>
+        </p:txBody>
+      </p:sp>
+      <p:pic>
+        <p:nvPicPr>
+          <p:cNvPr id="7" name="Picture 6" descr="s_skill2_ladder.png"/>
+          <p:cNvPicPr>
+            <a:picLocks noChangeAspect="1"/>
+          </p:cNvPicPr>
+          <p:nvPr/>
+        </p:nvPicPr>
+        <p:blipFill>
+          <a:blip r:embed="rId2"/>
+          <a:stretch>
+            <a:fillRect/>
+          </a:stretch>
+        </p:blipFill>
+        <p:spPr>
+          <a:xfrm>
+            <a:off x="457200" y="1417321"/>
+            <a:ext cx="8229600" cy="3031308"/>
+          </a:xfrm>
+          <a:prstGeom prst="rect">
+            <a:avLst/>
+          </a:prstGeom>
+        </p:spPr>
+      </p:pic>
+    </p:spTree>
+  </p:cSld>
+  <p:clrMapOvr>
+    <a:masterClrMapping/>
+  </p:clrMapOvr>
+</p:sld>
+</file>
+
+<file path=ppt/slides/slide19.xml><?xml version="1.0" encoding="utf-8"?>
+<p:sld xmlns:a="http://schemas.openxmlformats.org/drawingml/2006/main" xmlns:p="http://schemas.openxmlformats.org/presentationml/2006/main" xmlns:r="http://schemas.openxmlformats.org/officeDocument/2006/relationships">
+  <p:cSld>
+    <p:spTree>
+      <p:nvGrpSpPr>
+        <p:cNvPr id="1" name=""/>
+        <p:cNvGrpSpPr/>
+        <p:nvPr/>
+      </p:nvGrpSpPr>
+      <p:grpSpPr/>
+      <p:sp>
+        <p:nvSpPr>
+          <p:cNvPr id="2" name="Text 0"/>
+          <p:cNvSpPr/>
+          <p:nvPr/>
+        </p:nvSpPr>
+        <p:spPr>
+          <a:xfrm>
+            <a:off x="548640" y="182880"/>
+            <a:ext cx="8229600" cy="548640"/>
+          </a:xfrm>
+          <a:prstGeom prst="rect">
+            <a:avLst/>
+          </a:prstGeom>
+          <a:noFill/>
+          <a:ln/>
+        </p:spPr>
+        <p:txBody>
+          <a:bodyPr wrap="square" lIns="0" tIns="0" rIns="0" bIns="0" rtlCol="0" anchor="ctr"/>
+          <a:lstStyle/>
+          <a:p>
+            <a:pPr marL="0" indent="0">
+              <a:buNone/>
+            </a:pPr>
+            <a:r>
+              <a:rPr sz="3600" b="1">
+                <a:solidFill>
+                  <a:srgbClr val="1E3A5F"/>
+                </a:solidFill>
+                <a:latin typeface="Georgia"/>
+              </a:rPr>
+              <a:t>You Try</a:t>
+            </a:r>
+            <a:endParaRPr lang="en-US" sz="2600" dirty="0"/>
+          </a:p>
+        </p:txBody>
+      </p:sp>
+      <p:sp>
+        <p:nvSpPr>
+          <p:cNvPr id="3" name="Shape 1"/>
+          <p:cNvSpPr/>
+          <p:nvPr/>
+        </p:nvSpPr>
+        <p:spPr>
+          <a:xfrm>
+            <a:off x="457200" y="731520"/>
+            <a:ext cx="8229600" cy="548640"/>
+          </a:xfrm>
+          <a:prstGeom prst="rect">
+            <a:avLst/>
+          </a:prstGeom>
+          <a:solidFill>
+            <a:srgbClr val="0F2B46"/>
+          </a:solidFill>
+          <a:ln/>
+        </p:spPr>
+        <p:txBody>
+          <a:bodyPr/>
+          <a:lstStyle/>
+          <a:p>
+            <a:endParaRPr lang="en-US"/>
+          </a:p>
+        </p:txBody>
+      </p:sp>
+      <p:sp>
+        <p:nvSpPr>
+          <p:cNvPr id="4" name="Text 2"/>
+          <p:cNvSpPr/>
+          <p:nvPr/>
+        </p:nvSpPr>
+        <p:spPr>
+          <a:xfrm>
+            <a:off x="640080" y="731520"/>
+            <a:ext cx="7772400" cy="548640"/>
+          </a:xfrm>
+          <a:prstGeom prst="rect">
+            <a:avLst/>
+          </a:prstGeom>
+          <a:noFill/>
+          <a:ln/>
+        </p:spPr>
+        <p:txBody>
+          <a:bodyPr wrap="square" lIns="0" tIns="0" rIns="0" bIns="0" rtlCol="0" anchor="ctr"/>
+          <a:lstStyle/>
+          <a:p>
+            <a:pPr marL="0" indent="0">
+              <a:buNone/>
+            </a:pPr>
+            <a:r>
+              <a:rPr sz="1600" b="0">
+                <a:solidFill>
+                  <a:srgbClr val="FFFFFF"/>
+                </a:solidFill>
+                <a:latin typeface="Calibri"/>
+              </a:rPr>
+              <a:t>A surveyor stands 80 ft from a building. The angle of elevation to the roof is 42°. Find the building height.</a:t>
+            </a:r>
+            <a:endParaRPr lang="en-US" sz="1300" dirty="0"/>
+          </a:p>
+        </p:txBody>
+      </p:sp>
+      <p:sp>
+        <p:nvSpPr>
+          <p:cNvPr id="6" name="Shape 3"/>
+          <p:cNvSpPr/>
+          <p:nvPr/>
+        </p:nvSpPr>
+        <p:spPr>
+          <a:xfrm>
+            <a:off x="274320" y="1417320"/>
+            <a:ext cx="4297680" cy="3291840"/>
+          </a:xfrm>
+          <a:prstGeom prst="rect">
+            <a:avLst/>
+          </a:prstGeom>
+          <a:solidFill>
+            <a:srgbClr val="FFFFFF"/>
+          </a:solidFill>
+          <a:ln/>
+          <a:effectLst>
+            <a:outerShdw blurRad="76200" dist="25400" dir="8100000" algn="bl" rotWithShape="0">
+              <a:srgbClr val="000000">
+                <a:alpha val="10000"/>
+              </a:srgbClr>
+            </a:outerShdw>
+          </a:effectLst>
+        </p:spPr>
+        <p:txBody>
+          <a:bodyPr/>
+          <a:lstStyle/>
+          <a:p>
+            <a:endParaRPr lang="en-US"/>
+          </a:p>
+        </p:txBody>
+      </p:sp>
+      <p:sp>
+        <p:nvSpPr>
+          <p:cNvPr id="7" name="Text 4"/>
+          <p:cNvSpPr/>
+          <p:nvPr/>
+        </p:nvSpPr>
+        <p:spPr>
+          <a:xfrm>
+            <a:off x="457200" y="1554480"/>
+            <a:ext cx="3931920" cy="3017520"/>
+          </a:xfrm>
+          <a:prstGeom prst="rect">
+            <a:avLst/>
+          </a:prstGeom>
+          <a:noFill/>
+          <a:ln/>
+        </p:spPr>
+        <p:txBody>
+          <a:bodyPr wrap="square" rtlCol="0" anchor="ctr"/>
+          <a:lstStyle/>
+          <a:p>
+            <a:pPr marL="0" indent="0">
+              <a:spcAft>
+                <a:spcPts val="100"/>
+              </a:spcAft>
+              <a:buNone/>
+            </a:pPr>
+            <a:r>
+              <a:rPr sz="1700" b="1">
+                <a:solidFill>
+                  <a:srgbClr val="0891B2"/>
+                </a:solidFill>
+                <a:latin typeface="Calibri"/>
+              </a:rPr>
+              <a:t>Set up:</a:t>
+            </a:r>
+            <a:endParaRPr lang="en-US" sz="1300" dirty="0"/>
+          </a:p>
+          <a:p>
+            <a:r>
+              <a:rPr sz="1700">
+                <a:latin typeface="Calibri"/>
+              </a:rPr>
+              <a:t>tan 42° = h / 80</a:t>
+            </a:r>
+          </a:p>
+          <a:p/>
+          <a:p>
+            <a:r>
+              <a:rPr sz="1700" b="1">
+                <a:solidFill>
+                  <a:srgbClr val="7C3AED"/>
+                </a:solidFill>
+                <a:latin typeface="Calibri"/>
+              </a:rPr>
+              <a:t>Solve:</a:t>
+            </a:r>
+          </a:p>
+          <a:p>
+            <a:r>
+              <a:rPr sz="1700">
+                <a:latin typeface="Calibri"/>
+              </a:rPr>
+              <a:t>h = 80 × tan 42°</a:t>
+            </a:r>
+          </a:p>
+          <a:p>
+            <a:r>
+              <a:rPr sz="1700">
+                <a:latin typeface="Calibri"/>
+              </a:rPr>
+              <a:t>h = 80 × 0.9004</a:t>
+            </a:r>
+          </a:p>
+          <a:p>
+            <a:r>
+              <a:rPr sz="1800" b="1">
+                <a:solidFill>
+                  <a:srgbClr val="F97316"/>
+                </a:solidFill>
+                <a:latin typeface="Calibri"/>
+              </a:rPr>
+              <a:t>h ≈ 72.0 ft</a:t>
+            </a:r>
+          </a:p>
+          <a:p/>
+          <a:p>
+            <a:r>
+              <a:rPr sz="1700" b="1">
+                <a:solidFill>
+                  <a:srgbClr val="059669"/>
+                </a:solidFill>
+                <a:latin typeface="Calibri"/>
+              </a:rPr>
+              <a:t>Check:</a:t>
+            </a:r>
+          </a:p>
+          <a:p>
+            <a:r>
+              <a:rPr sz="1400" b="0">
+                <a:latin typeface="Calibri"/>
+              </a:rPr>
+              <a:t>72.0 ft &lt; 80 ft  ✓  (height &lt; base distance for 42° &lt; 45°)</a:t>
+            </a:r>
+          </a:p>
+        </p:txBody>
+      </p:sp>
+      <p:pic>
+        <p:nvPicPr>
+          <p:cNvPr id="8" name="Picture 7" descr="s_you_try.png"/>
+          <p:cNvPicPr>
+            <a:picLocks noChangeAspect="1"/>
+          </p:cNvPicPr>
+          <p:nvPr/>
+        </p:nvPicPr>
+        <p:blipFill>
+          <a:blip r:embed="rId2"/>
+          <a:stretch>
+            <a:fillRect/>
+          </a:stretch>
+        </p:blipFill>
+        <p:spPr>
+          <a:xfrm>
+            <a:off x="4754880" y="1188720"/>
+            <a:ext cx="4206240" cy="3108960"/>
+          </a:xfrm>
+          <a:prstGeom prst="rect">
+            <a:avLst/>
+          </a:prstGeom>
+        </p:spPr>
+      </p:pic>
     </p:spTree>
   </p:cSld>
   <p:clrMapOvr>
@@ -8784,115 +9233,86 @@
               <a:buNone/>
             </a:pPr>
             <a:r>
-              <a:rPr lang="en-US" sz="1500" dirty="0">
-                <a:solidFill>
-                  <a:srgbClr val="1E293B"/>
-                </a:solidFill>
-                <a:latin typeface="Calibri" pitchFamily="34" charset="0"/>
-                <a:ea typeface="Calibri" pitchFamily="34" charset="-122"/>
-                <a:cs typeface="Calibri" pitchFamily="34" charset="-120"/>
+              <a:rPr sz="1800">
+                <a:latin typeface="Calibri"/>
               </a:rPr>
               <a:t>sin A = opp / hyp = 7 / 15 ≈ 0.4667</a:t>
             </a:r>
             <a:endParaRPr lang="en-US" sz="1500" dirty="0"/>
           </a:p>
-          <a:p>
-            <a:pPr marL="0" indent="0">
-              <a:spcAft>
-                <a:spcPts val="300"/>
-              </a:spcAft>
-              <a:buNone/>
-            </a:pPr>
-            <a:endParaRPr lang="en-US" sz="1500" dirty="0"/>
-          </a:p>
-          <a:p>
-            <a:pPr marL="0" indent="0">
-              <a:spcAft>
-                <a:spcPts val="300"/>
-              </a:spcAft>
-              <a:buNone/>
-            </a:pPr>
-            <a:r>
-              <a:rPr lang="en-US" sz="1600" dirty="0">
-                <a:solidFill>
-                  <a:srgbClr val="1E293B"/>
-                </a:solidFill>
-                <a:latin typeface="Calibri" pitchFamily="34" charset="0"/>
-                <a:ea typeface="Calibri" pitchFamily="34" charset="-122"/>
-                <a:cs typeface="Calibri" pitchFamily="34" charset="-120"/>
+          <a:p/>
+          <a:p>
+            <a:r>
+              <a:rPr sz="1800">
+                <a:latin typeface="Calibri"/>
               </a:rPr>
               <a:t>A = sin⁻¹(0.4667)</a:t>
             </a:r>
-            <a:endParaRPr lang="en-US" sz="1500" dirty="0"/>
-          </a:p>
-          <a:p>
-            <a:pPr marL="0" indent="0">
-              <a:spcAft>
-                <a:spcPts val="300"/>
-              </a:spcAft>
-              <a:buNone/>
-            </a:pPr>
-            <a:r>
-              <a:rPr lang="en-US" sz="2000" b="1" dirty="0">
+          </a:p>
+          <a:p>
+            <a:r>
+              <a:rPr sz="2000" b="1">
                 <a:solidFill>
                   <a:srgbClr val="F97316"/>
                 </a:solidFill>
-                <a:latin typeface="Georgia" pitchFamily="34" charset="0"/>
-                <a:ea typeface="Georgia" pitchFamily="34" charset="-122"/>
-                <a:cs typeface="Georgia" pitchFamily="34" charset="-120"/>
+                <a:latin typeface="Calibri"/>
               </a:rPr>
               <a:t>A ≈ 27.8°</a:t>
             </a:r>
-            <a:endParaRPr lang="en-US" sz="1500" dirty="0"/>
-          </a:p>
-          <a:p>
-            <a:pPr marL="0" indent="0">
-              <a:spcAft>
-                <a:spcPts val="300"/>
-              </a:spcAft>
-              <a:buNone/>
-            </a:pPr>
-            <a:endParaRPr lang="en-US" sz="1500" dirty="0"/>
-          </a:p>
-          <a:p>
-            <a:pPr marL="0" indent="0">
-              <a:spcAft>
-                <a:spcPts val="300"/>
-              </a:spcAft>
-              <a:buNone/>
-            </a:pPr>
-            <a:r>
-              <a:rPr lang="en-US" sz="1300" i="1" dirty="0">
+          </a:p>
+          <a:p/>
+          <a:p>
+            <a:r>
+              <a:rPr sz="1400" b="0">
                 <a:solidFill>
                   <a:srgbClr val="64748B"/>
                 </a:solidFill>
-                <a:latin typeface="Calibri" pitchFamily="34" charset="0"/>
-                <a:ea typeface="Calibri" pitchFamily="34" charset="-122"/>
-                <a:cs typeface="Calibri" pitchFamily="34" charset="-120"/>
+                <a:latin typeface="Calibri"/>
               </a:rPr>
               <a:t>Use sin⁻¹ (arcsin), cos⁻¹, or tan⁻¹ to find angles.</a:t>
             </a:r>
-            <a:endParaRPr lang="en-US" sz="1500" dirty="0"/>
-          </a:p>
-          <a:p>
-            <a:pPr marL="0" indent="0">
-              <a:spcAft>
-                <a:spcPts val="300"/>
-              </a:spcAft>
-              <a:buNone/>
-            </a:pPr>
-            <a:r>
-              <a:rPr lang="en-US" sz="1300" b="1" dirty="0">
+          </a:p>
+        </p:txBody>
+      </p:sp>
+      <p:sp>
+        <p:nvSpPr>
+          <p:cNvPr id="8" name="TextBox 7"/>
+          <p:cNvSpPr txBox="1"/>
+          <p:nvPr/>
+        </p:nvSpPr>
+        <p:spPr>
+          <a:xfrm>
+            <a:off x="640080" y="3520440"/>
+            <a:ext cx="4572000" cy="594360"/>
+          </a:xfrm>
+          <a:prstGeom prst="rect">
+            <a:avLst/>
+          </a:prstGeom>
+          <a:solidFill>
+            <a:srgbClr val="FFEDED"/>
+          </a:solidFill>
+          <a:ln w="19050">
+            <a:solidFill>
+              <a:srgbClr val="DC2626"/>
+            </a:solidFill>
+          </a:ln>
+        </p:spPr>
+        <p:txBody>
+          <a:bodyPr wrap="square">
+            <a:spAutoFit/>
+          </a:bodyPr>
+          <a:lstStyle/>
+          <a:p>
+            <a:pPr algn="ctr"/>
+            <a:r>
+              <a:rPr sz="1500" b="1">
                 <a:solidFill>
                   <a:srgbClr val="DC2626"/>
                 </a:solidFill>
-                <a:latin typeface="Calibri" pitchFamily="34" charset="0"/>
-                <a:ea typeface="Calibri" pitchFamily="34" charset="-122"/>
-                <a:cs typeface="Calibri" pitchFamily="34" charset="-120"/>
-              </a:rPr>
-              <a:t>Make sure calculator is in DEGREE mode!</a:t>
-            </a:r>
-            <a:endParaRPr lang="en-US" sz="1500" dirty="0"/>
+                <a:latin typeface="Calibri"/>
+              </a:rPr>
+              <a:t>⚠  Calculator must be in DEGREE mode when using inverse trig!</a:t>
+            </a:r>
           </a:p>
         </p:txBody>
       </p:sp>
@@ -9449,7 +9869,7 @@
             <a:r>
               <a:rPr lang="en-US" sz="1300" i="1" dirty="0">
                 <a:solidFill>
-                  <a:srgbClr val="64748B"/>
+                  <a:srgbClr val="0891B2"/>
                 </a:solidFill>
                 <a:latin typeface="Calibri" pitchFamily="34" charset="0"/>
                 <a:ea typeface="Calibri" pitchFamily="34" charset="-122"/>
@@ -10006,7 +10426,7 @@
             <a:r>
               <a:rPr lang="en-US" sz="1400" b="1" dirty="0">
                 <a:solidFill>
-                  <a:srgbClr val="7C3AED"/>
+                  <a:srgbClr val="0891B2"/>
                 </a:solidFill>
                 <a:latin typeface="Georgia" pitchFamily="34" charset="0"/>
                 <a:ea typeface="Georgia" pitchFamily="34" charset="-122"/>

</xml_diff>